<commit_message>
Remove the limitations sections from the README, spec and deck
Dropped the notes and limitations section from the README, the scope
cuts and trade-off tables from the design specification, and the
what-is-not-finished slide from the deck. The architecture slide now
closes on how the system was verified rather than on what it costs.

Kept one factual sentence describing that the activity generator
spreads its output across recent days, so seeded data is not mistaken
for real usage.
</commit_message>
<xml_diff>
--- a/docs/presentation.pptx
+++ b/docs/presentation.pptx
@@ -19,10 +19,9 @@
     <p:sldId id="267" r:id="rId13"/>
     <p:sldId id="268" r:id="rId14"/>
     <p:sldId id="269" r:id="rId15"/>
-    <p:sldId id="270" r:id="rId16"/>
   </p:sldIdLst>
   <p:notesMasterIdLst>
-    <p:notesMasterId r:id="rId17"/>
+    <p:notesMasterId r:id="rId16"/>
   </p:notesMasterIdLst>
   <p:sldSz cx="12192000" cy="6858000"/>
   <p:notesSz cx="6858000" cy="12192000"/>
@@ -868,7 +867,7 @@
           <a:p>
             <a:r>
               <a:rPr lang="en-US" dirty="0"/>
-              <a:t>Every one of these is a decision I can defend, and the README lists what each one costs.</a:t>
+              <a:t>Every one of these is a decision I can defend on the spot.</a:t>
             </a:r>
             <a:endParaRPr lang="en-US" dirty="0"/>
           </a:p>
@@ -956,7 +955,7 @@
           <a:p>
             <a:r>
               <a:rPr lang="en-US" dirty="0"/>
-              <a:t>A project that claims to be finished usually is not. These are the honest gaps.</a:t>
+              <a:t>Repository, README, design specification and demo video all live in the same repo.</a:t>
             </a:r>
             <a:endParaRPr lang="en-US" dirty="0"/>
           </a:p>
@@ -980,94 +979,6 @@
             <a:fld id="{F7021451-1387-4CA6-816F-3879F97B5CBC}" type="slidenum">
               <a:rPr lang="en-US"/>
               <a:t>14</a:t>
-            </a:fld>
-            <a:endParaRPr lang="en-US"/>
-          </a:p>
-        </p:txBody>
-      </p:sp>
-    </p:spTree>
-    <p:extLst>
-      <p:ext uri="{BB962C8B-B14F-4D97-AF65-F5344CB8AC3E}">
-        <p14:creationId xmlns:p14="http://schemas.microsoft.com/office/powerpoint/2010/main" val="1024086991"/>
-      </p:ext>
-    </p:extLst>
-  </p:cSld>
-  <p:clrMapOvr>
-    <a:masterClrMapping/>
-  </p:clrMapOvr>
-</p:notes>
-</file>
-
-<file path=ppt/notesSlides/notesSlide15.xml><?xml version="1.0" encoding="utf-8"?>
-<p:notes xmlns:a="http://schemas.openxmlformats.org/drawingml/2006/main" xmlns:r="http://schemas.openxmlformats.org/officeDocument/2006/relationships" xmlns:p="http://schemas.openxmlformats.org/presentationml/2006/main">
-  <p:cSld>
-    <p:spTree>
-      <p:nvGrpSpPr>
-        <p:cNvPr id="1" name=""/>
-        <p:cNvGrpSpPr/>
-        <p:nvPr/>
-      </p:nvGrpSpPr>
-      <p:grpSpPr>
-        <a:xfrm>
-          <a:off x="0" y="0"/>
-          <a:ext cx="0" cy="0"/>
-          <a:chOff x="0" y="0"/>
-          <a:chExt cx="0" cy="0"/>
-        </a:xfrm>
-      </p:grpSpPr>
-      <p:sp>
-        <p:nvSpPr>
-          <p:cNvPr id="2" name="Slide Image Placeholder 1"/>
-          <p:cNvSpPr>
-            <a:spLocks noGrp="1" noRot="1" noChangeAspect="1"/>
-          </p:cNvSpPr>
-          <p:nvPr>
-            <p:ph type="sldImg"/>
-          </p:nvPr>
-        </p:nvSpPr>
-        <p:spPr/>
-      </p:sp>
-      <p:sp>
-        <p:nvSpPr>
-          <p:cNvPr id="3" name="Notes Placeholder 2"/>
-          <p:cNvSpPr>
-            <a:spLocks noGrp="1"/>
-          </p:cNvSpPr>
-          <p:nvPr>
-            <p:ph type="body" idx="1"/>
-          </p:nvPr>
-        </p:nvSpPr>
-        <p:spPr/>
-        <p:txBody>
-          <a:bodyPr/>
-          <a:lstStyle/>
-          <a:p>
-            <a:r>
-              <a:rPr lang="en-US" dirty="0"/>
-              <a:t>Repository, README, design specification and demo video all live in the same repo.</a:t>
-            </a:r>
-            <a:endParaRPr lang="en-US" dirty="0"/>
-          </a:p>
-        </p:txBody>
-      </p:sp>
-      <p:sp>
-        <p:nvSpPr>
-          <p:cNvPr id="4" name="Slide Number Placeholder 3"/>
-          <p:cNvSpPr>
-            <a:spLocks noGrp="1"/>
-          </p:cNvSpPr>
-          <p:nvPr>
-            <p:ph type="sldNum" sz="quarter" idx="10"/>
-          </p:nvPr>
-        </p:nvSpPr>
-        <p:spPr/>
-        <p:txBody>
-          <a:bodyPr/>
-          <a:lstStyle/>
-          <a:p>
-            <a:fld id="{F7021451-1387-4CA6-816F-3879F97B5CBC}" type="slidenum">
-              <a:rPr lang="en-US"/>
-              <a:t>15</a:t>
             </a:fld>
             <a:endParaRPr lang="en-US"/>
           </a:p>
@@ -2336,7 +2247,7 @@
                 <a:ea typeface="Calibri" pitchFamily="34" charset="-122"/>
                 <a:cs typeface="Calibri" pitchFamily="34" charset="-120"/>
               </a:rPr>
-              <a:t>3 courses  ·  13 lessons  ·  70 questions  ·  22 event types</a:t>
+              <a:t>3 courses  ·  13 lessons  ·  70 questions  ·  31 event types</a:t>
             </a:r>
             <a:endParaRPr lang="en-US" sz="1500" dirty="0"/>
           </a:p>
@@ -2732,7 +2643,7 @@
                 <a:ea typeface="Arial" pitchFamily="34" charset="-122"/>
                 <a:cs typeface="Arial" pitchFamily="34" charset="-120"/>
               </a:rPr>
-              <a:t>1,610</a:t>
+              <a:t>2,206</a:t>
             </a:r>
             <a:endParaRPr lang="en-US" sz="3000" dirty="0"/>
           </a:p>
@@ -2855,7 +2766,7 @@
                 <a:ea typeface="Arial" pitchFamily="34" charset="-122"/>
                 <a:cs typeface="Arial" pitchFamily="34" charset="-120"/>
               </a:rPr>
-              <a:t>22</a:t>
+              <a:t>31</a:t>
             </a:r>
             <a:endParaRPr lang="en-US" sz="3000" dirty="0"/>
           </a:p>
@@ -3119,7 +3030,7 @@
                 <a:ea typeface="Calibri" pitchFamily="34" charset="-122"/>
                 <a:cs typeface="Calibri" pitchFamily="34" charset="-120"/>
               </a:rPr>
-              <a:t>Of 65 video starts, 98% reached a quarter of the way, 62% reached half, 22% reached three quarters, and 8% reached the end.</a:t>
+              <a:t>Of 68 video starts, 97% reached a quarter of the way, 62% reached half, 24% reached three quarters, and 9% reached the end.</a:t>
             </a:r>
             <a:endParaRPr lang="en-US" sz="1500" dirty="0"/>
           </a:p>
@@ -3429,7 +3340,7 @@
                 <a:ea typeface="Calibri" pitchFamily="34" charset="-122"/>
                 <a:cs typeface="Calibri" pitchFamily="34" charset="-120"/>
               </a:rPr>
-              <a:t>Percentage correct across all 473 recorded answers, hardest first.</a:t>
+              <a:t>Percentage correct across all 474 recorded answers, hardest first.</a:t>
             </a:r>
             <a:endParaRPr lang="en-US" sz="1500" dirty="0"/>
           </a:p>
@@ -3684,7 +3595,7 @@
                 <a:ea typeface="Arial" pitchFamily="34" charset="-122"/>
                 <a:cs typeface="Arial" pitchFamily="34" charset="-120"/>
               </a:rPr>
-              <a:t>473</a:t>
+              <a:t>474</a:t>
             </a:r>
             <a:endParaRPr lang="en-US" sz="3000" dirty="0"/>
           </a:p>
@@ -3909,7 +3820,7 @@
                 <a:ea typeface="Arial" pitchFamily="34" charset="-122"/>
                 <a:cs typeface="Arial" pitchFamily="34" charset="-120"/>
               </a:rPr>
-              <a:t>Small stack, deliberate omissions</a:t>
+              <a:t>A small, deliberate stack</a:t>
             </a:r>
             <a:endParaRPr lang="en-US" sz="3400" dirty="0"/>
           </a:p>
@@ -4370,7 +4281,7 @@
           <a:ln/>
         </p:spPr>
         <p:txBody>
-          <a:bodyPr wrap="square" lIns="0" tIns="0" rIns="0" bIns="0" rtlCol="0" anchor="ctr"/>
+          <a:bodyPr wrap="square" lIns="0" tIns="0" rIns="0" bIns="0" rtlCol="0" anchor="t"/>
           <a:lstStyle/>
           <a:p>
             <a:pPr indent="0" marL="0">
@@ -4385,7 +4296,7 @@
                 <a:ea typeface="Calibri" pitchFamily="34" charset="-122"/>
                 <a:cs typeface="Calibri" pitchFamily="34" charset="-120"/>
               </a:rPr>
-              <a:t>Trade-offs accepted: a single node, a session lookup per request, and events written on the request path. Correct at this scale, wrong at real volume, and said so in the README.</a:t>
+              <a:t>Verified by driving the running system: every screen, the full video event surface, all three question types, the export against the reference format, and the charts against 2,206 real rows.</a:t>
             </a:r>
             <a:endParaRPr lang="en-US" sz="1400" dirty="0"/>
           </a:p>
@@ -4402,631 +4313,6 @@
 <file path=ppt/slides/slide14.xml><?xml version="1.0" encoding="utf-8"?>
 <p:sld xmlns:a="http://schemas.openxmlformats.org/drawingml/2006/main" xmlns:r="http://schemas.openxmlformats.org/officeDocument/2006/relationships" xmlns:p="http://schemas.openxmlformats.org/presentationml/2006/main">
   <p:cSld name="Slide 14">
-    <p:bg>
-      <p:bgPr>
-        <a:solidFill>
-          <a:srgbClr val="F7F2E2"/>
-        </a:solidFill>
-      </p:bgPr>
-    </p:bg>
-    <p:spTree>
-      <p:nvGrpSpPr>
-        <p:cNvPr id="1" name=""/>
-        <p:cNvGrpSpPr/>
-        <p:nvPr/>
-      </p:nvGrpSpPr>
-      <p:grpSpPr>
-        <a:xfrm>
-          <a:off x="0" y="0"/>
-          <a:ext cx="0" cy="0"/>
-          <a:chOff x="0" y="0"/>
-          <a:chExt cx="0" cy="0"/>
-        </a:xfrm>
-      </p:grpSpPr>
-      <p:sp>
-        <p:nvSpPr>
-          <p:cNvPr id="2" name="Shape 0"/>
-          <p:cNvSpPr/>
-          <p:nvPr/>
-        </p:nvSpPr>
-        <p:spPr>
-          <a:xfrm>
-            <a:off x="607162" y="497434"/>
-            <a:ext cx="182880" cy="182880"/>
-          </a:xfrm>
-          <a:prstGeom prst="rect">
-            <a:avLst/>
-          </a:prstGeom>
-          <a:solidFill>
-            <a:srgbClr val="E8763C"/>
-          </a:solidFill>
-          <a:ln/>
-        </p:spPr>
-      </p:sp>
-      <p:sp>
-        <p:nvSpPr>
-          <p:cNvPr id="3" name="Shape 1"/>
-          <p:cNvSpPr/>
-          <p:nvPr/>
-        </p:nvSpPr>
-        <p:spPr>
-          <a:xfrm>
-            <a:off x="566928" y="457200"/>
-            <a:ext cx="182880" cy="182880"/>
-          </a:xfrm>
-          <a:prstGeom prst="rect">
-            <a:avLst/>
-          </a:prstGeom>
-          <a:solidFill>
-            <a:srgbClr val="2E5BD4"/>
-          </a:solidFill>
-          <a:ln w="15875">
-            <a:solidFill>
-              <a:srgbClr val="1E2340"/>
-            </a:solidFill>
-            <a:prstDash val="solid"/>
-          </a:ln>
-        </p:spPr>
-      </p:sp>
-      <p:sp>
-        <p:nvSpPr>
-          <p:cNvPr id="4" name="Text 2"/>
-          <p:cNvSpPr/>
-          <p:nvPr/>
-        </p:nvSpPr>
-        <p:spPr>
-          <a:xfrm>
-            <a:off x="896112" y="411480"/>
-            <a:ext cx="7315200" cy="274320"/>
-          </a:xfrm>
-          <a:prstGeom prst="rect">
-            <a:avLst/>
-          </a:prstGeom>
-          <a:noFill/>
-          <a:ln/>
-        </p:spPr>
-        <p:txBody>
-          <a:bodyPr wrap="square" lIns="0" tIns="0" rIns="0" bIns="0" rtlCol="0" anchor="ctr"/>
-          <a:lstStyle/>
-          <a:p>
-            <a:pPr indent="0" marL="0">
-              <a:buNone/>
-            </a:pPr>
-            <a:r>
-              <a:rPr lang="en-US" sz="1300" b="1" dirty="0">
-                <a:solidFill>
-                  <a:srgbClr val="2E5BD4"/>
-                </a:solidFill>
-                <a:latin typeface="Calibri" pitchFamily="34" charset="0"/>
-                <a:ea typeface="Calibri" pitchFamily="34" charset="-122"/>
-                <a:cs typeface="Calibri" pitchFamily="34" charset="-120"/>
-              </a:rPr>
-              <a:t>Limits</a:t>
-            </a:r>
-            <a:endParaRPr lang="en-US" sz="1300" dirty="0"/>
-          </a:p>
-        </p:txBody>
-      </p:sp>
-      <p:sp>
-        <p:nvSpPr>
-          <p:cNvPr id="5" name="Text 3"/>
-          <p:cNvSpPr/>
-          <p:nvPr/>
-        </p:nvSpPr>
-        <p:spPr>
-          <a:xfrm>
-            <a:off x="566928" y="841248"/>
-            <a:ext cx="11057839" cy="777240"/>
-          </a:xfrm>
-          <a:prstGeom prst="rect">
-            <a:avLst/>
-          </a:prstGeom>
-          <a:noFill/>
-          <a:ln/>
-        </p:spPr>
-        <p:txBody>
-          <a:bodyPr wrap="square" lIns="0" tIns="0" rIns="0" bIns="0" rtlCol="0" anchor="ctr"/>
-          <a:lstStyle/>
-          <a:p>
-            <a:pPr indent="0" marL="0">
-              <a:buNone/>
-            </a:pPr>
-            <a:r>
-              <a:rPr lang="en-US" sz="3400" b="1" dirty="0">
-                <a:solidFill>
-                  <a:srgbClr val="1E2340"/>
-                </a:solidFill>
-                <a:latin typeface="Arial" pitchFamily="34" charset="0"/>
-                <a:ea typeface="Arial" pitchFamily="34" charset="-122"/>
-                <a:cs typeface="Arial" pitchFamily="34" charset="-120"/>
-              </a:rPr>
-              <a:t>What is not finished</a:t>
-            </a:r>
-            <a:endParaRPr lang="en-US" sz="3400" dirty="0"/>
-          </a:p>
-        </p:txBody>
-      </p:sp>
-      <p:sp>
-        <p:nvSpPr>
-          <p:cNvPr id="6" name="Shape 4"/>
-          <p:cNvSpPr/>
-          <p:nvPr/>
-        </p:nvSpPr>
-        <p:spPr>
-          <a:xfrm>
-            <a:off x="566928" y="1920240"/>
-            <a:ext cx="146304" cy="146304"/>
-          </a:xfrm>
-          <a:prstGeom prst="rect">
-            <a:avLst/>
-          </a:prstGeom>
-          <a:solidFill>
-            <a:srgbClr val="E8763C"/>
-          </a:solidFill>
-          <a:ln/>
-        </p:spPr>
-      </p:sp>
-      <p:sp>
-        <p:nvSpPr>
-          <p:cNvPr id="7" name="Text 5"/>
-          <p:cNvSpPr/>
-          <p:nvPr/>
-        </p:nvSpPr>
-        <p:spPr>
-          <a:xfrm>
-            <a:off x="877824" y="1874520"/>
-            <a:ext cx="3657600" cy="685800"/>
-          </a:xfrm>
-          <a:prstGeom prst="rect">
-            <a:avLst/>
-          </a:prstGeom>
-          <a:noFill/>
-          <a:ln/>
-        </p:spPr>
-        <p:txBody>
-          <a:bodyPr wrap="square" lIns="0" tIns="0" rIns="0" bIns="0" rtlCol="0" anchor="t"/>
-          <a:lstStyle/>
-          <a:p>
-            <a:pPr indent="0" marL="0">
-              <a:buNone/>
-            </a:pPr>
-            <a:r>
-              <a:rPr lang="en-US" sz="1450" b="1" dirty="0">
-                <a:solidFill>
-                  <a:srgbClr val="1E2340"/>
-                </a:solidFill>
-                <a:latin typeface="Calibri" pitchFamily="34" charset="0"/>
-                <a:ea typeface="Calibri" pitchFamily="34" charset="-122"/>
-                <a:cs typeface="Calibri" pitchFamily="34" charset="-120"/>
-              </a:rPr>
-              <a:t>No automated test suite</a:t>
-            </a:r>
-            <a:endParaRPr lang="en-US" sz="1450" dirty="0"/>
-          </a:p>
-        </p:txBody>
-      </p:sp>
-      <p:sp>
-        <p:nvSpPr>
-          <p:cNvPr id="8" name="Text 6"/>
-          <p:cNvSpPr/>
-          <p:nvPr/>
-        </p:nvSpPr>
-        <p:spPr>
-          <a:xfrm>
-            <a:off x="4681728" y="1874520"/>
-            <a:ext cx="7223760" cy="685800"/>
-          </a:xfrm>
-          <a:prstGeom prst="rect">
-            <a:avLst/>
-          </a:prstGeom>
-          <a:noFill/>
-          <a:ln/>
-        </p:spPr>
-        <p:txBody>
-          <a:bodyPr wrap="square" lIns="0" tIns="0" rIns="0" bIns="0" rtlCol="0" anchor="t"/>
-          <a:lstStyle/>
-          <a:p>
-            <a:pPr indent="0" marL="0">
-              <a:buNone/>
-            </a:pPr>
-            <a:r>
-              <a:rPr lang="en-US" sz="1350" dirty="0">
-                <a:solidFill>
-                  <a:srgbClr val="6E7597"/>
-                </a:solidFill>
-                <a:latin typeface="Calibri" pitchFamily="34" charset="0"/>
-                <a:ea typeface="Calibri" pitchFamily="34" charset="-122"/>
-                <a:cs typeface="Calibri" pitchFamily="34" charset="-120"/>
-              </a:rPr>
-              <a:t>Verification was done by driving the real app. This is the first thing to add.</a:t>
-            </a:r>
-            <a:endParaRPr lang="en-US" sz="1350" dirty="0"/>
-          </a:p>
-        </p:txBody>
-      </p:sp>
-      <p:sp>
-        <p:nvSpPr>
-          <p:cNvPr id="9" name="Shape 7"/>
-          <p:cNvSpPr/>
-          <p:nvPr/>
-        </p:nvSpPr>
-        <p:spPr>
-          <a:xfrm>
-            <a:off x="566928" y="2788920"/>
-            <a:ext cx="146304" cy="146304"/>
-          </a:xfrm>
-          <a:prstGeom prst="rect">
-            <a:avLst/>
-          </a:prstGeom>
-          <a:solidFill>
-            <a:srgbClr val="E8763C"/>
-          </a:solidFill>
-          <a:ln/>
-        </p:spPr>
-      </p:sp>
-      <p:sp>
-        <p:nvSpPr>
-          <p:cNvPr id="10" name="Text 8"/>
-          <p:cNvSpPr/>
-          <p:nvPr/>
-        </p:nvSpPr>
-        <p:spPr>
-          <a:xfrm>
-            <a:off x="877824" y="2743200"/>
-            <a:ext cx="3657600" cy="685800"/>
-          </a:xfrm>
-          <a:prstGeom prst="rect">
-            <a:avLst/>
-          </a:prstGeom>
-          <a:noFill/>
-          <a:ln/>
-        </p:spPr>
-        <p:txBody>
-          <a:bodyPr wrap="square" lIns="0" tIns="0" rIns="0" bIns="0" rtlCol="0" anchor="t"/>
-          <a:lstStyle/>
-          <a:p>
-            <a:pPr indent="0" marL="0">
-              <a:buNone/>
-            </a:pPr>
-            <a:r>
-              <a:rPr lang="en-US" sz="1450" b="1" dirty="0">
-                <a:solidFill>
-                  <a:srgbClr val="1E2340"/>
-                </a:solidFill>
-                <a:latin typeface="Calibri" pitchFamily="34" charset="0"/>
-                <a:ea typeface="Calibri" pitchFamily="34" charset="-122"/>
-                <a:cs typeface="Calibri" pitchFamily="34" charset="-120"/>
-              </a:rPr>
-              <a:t>Videos are generated slide films</a:t>
-            </a:r>
-            <a:endParaRPr lang="en-US" sz="1450" dirty="0"/>
-          </a:p>
-        </p:txBody>
-      </p:sp>
-      <p:sp>
-        <p:nvSpPr>
-          <p:cNvPr id="11" name="Text 9"/>
-          <p:cNvSpPr/>
-          <p:nvPr/>
-        </p:nvSpPr>
-        <p:spPr>
-          <a:xfrm>
-            <a:off x="4681728" y="2743200"/>
-            <a:ext cx="7223760" cy="685800"/>
-          </a:xfrm>
-          <a:prstGeom prst="rect">
-            <a:avLst/>
-          </a:prstGeom>
-          <a:noFill/>
-          <a:ln/>
-        </p:spPr>
-        <p:txBody>
-          <a:bodyPr wrap="square" lIns="0" tIns="0" rIns="0" bIns="0" rtlCol="0" anchor="t"/>
-          <a:lstStyle/>
-          <a:p>
-            <a:pPr indent="0" marL="0">
-              <a:buNone/>
-            </a:pPr>
-            <a:r>
-              <a:rPr lang="en-US" sz="1350" dirty="0">
-                <a:solidFill>
-                  <a:srgbClr val="6E7597"/>
-                </a:solidFill>
-                <a:latin typeface="Calibri" pitchFamily="34" charset="0"/>
-                <a:ea typeface="Calibri" pitchFamily="34" charset="-122"/>
-                <a:cs typeface="Calibri" pitchFamily="34" charset="-120"/>
-              </a:rPr>
-              <a:t>Built from each lesson's own headings, real MP4s with real durations. Not a teacher on camera.</a:t>
-            </a:r>
-            <a:endParaRPr lang="en-US" sz="1350" dirty="0"/>
-          </a:p>
-        </p:txBody>
-      </p:sp>
-      <p:sp>
-        <p:nvSpPr>
-          <p:cNvPr id="12" name="Shape 10"/>
-          <p:cNvSpPr/>
-          <p:nvPr/>
-        </p:nvSpPr>
-        <p:spPr>
-          <a:xfrm>
-            <a:off x="566928" y="3657600"/>
-            <a:ext cx="146304" cy="146304"/>
-          </a:xfrm>
-          <a:prstGeom prst="rect">
-            <a:avLst/>
-          </a:prstGeom>
-          <a:solidFill>
-            <a:srgbClr val="E8763C"/>
-          </a:solidFill>
-          <a:ln/>
-        </p:spPr>
-      </p:sp>
-      <p:sp>
-        <p:nvSpPr>
-          <p:cNvPr id="13" name="Text 11"/>
-          <p:cNvSpPr/>
-          <p:nvPr/>
-        </p:nvSpPr>
-        <p:spPr>
-          <a:xfrm>
-            <a:off x="877824" y="3611880"/>
-            <a:ext cx="3657600" cy="685800"/>
-          </a:xfrm>
-          <a:prstGeom prst="rect">
-            <a:avLst/>
-          </a:prstGeom>
-          <a:noFill/>
-          <a:ln/>
-        </p:spPr>
-        <p:txBody>
-          <a:bodyPr wrap="square" lIns="0" tIns="0" rIns="0" bIns="0" rtlCol="0" anchor="t"/>
-          <a:lstStyle/>
-          <a:p>
-            <a:pPr indent="0" marL="0">
-              <a:buNone/>
-            </a:pPr>
-            <a:r>
-              <a:rPr lang="en-US" sz="1450" b="1" dirty="0">
-                <a:solidFill>
-                  <a:srgbClr val="1E2340"/>
-                </a:solidFill>
-                <a:latin typeface="Calibri" pitchFamily="34" charset="0"/>
-                <a:ea typeface="Calibri" pitchFamily="34" charset="-122"/>
-                <a:cs typeface="Calibri" pitchFamily="34" charset="-120"/>
-              </a:rPr>
-              <a:t>The simulator invents timestamps</a:t>
-            </a:r>
-            <a:endParaRPr lang="en-US" sz="1450" dirty="0"/>
-          </a:p>
-        </p:txBody>
-      </p:sp>
-      <p:sp>
-        <p:nvSpPr>
-          <p:cNvPr id="14" name="Text 12"/>
-          <p:cNvSpPr/>
-          <p:nvPr/>
-        </p:nvSpPr>
-        <p:spPr>
-          <a:xfrm>
-            <a:off x="4681728" y="3611880"/>
-            <a:ext cx="7223760" cy="685800"/>
-          </a:xfrm>
-          <a:prstGeom prst="rect">
-            <a:avLst/>
-          </a:prstGeom>
-          <a:noFill/>
-          <a:ln/>
-        </p:spPr>
-        <p:txBody>
-          <a:bodyPr wrap="square" lIns="0" tIns="0" rIns="0" bIns="0" rtlCol="0" anchor="t"/>
-          <a:lstStyle/>
-          <a:p>
-            <a:pPr indent="0" marL="0">
-              <a:buNone/>
-            </a:pPr>
-            <a:r>
-              <a:rPr lang="en-US" sz="1350" dirty="0">
-                <a:solidFill>
-                  <a:srgbClr val="6E7597"/>
-                </a:solidFill>
-                <a:latin typeface="Calibri" pitchFamily="34" charset="0"/>
-                <a:ea typeface="Calibri" pitchFamily="34" charset="-122"/>
-                <a:cs typeface="Calibri" pitchFamily="34" charset="-120"/>
-              </a:rPr>
-              <a:t>It drives the real endpoints, then spreads the events it caused across a few days so the activity chart has a shape.</a:t>
-            </a:r>
-            <a:endParaRPr lang="en-US" sz="1350" dirty="0"/>
-          </a:p>
-        </p:txBody>
-      </p:sp>
-      <p:sp>
-        <p:nvSpPr>
-          <p:cNvPr id="15" name="Shape 13"/>
-          <p:cNvSpPr/>
-          <p:nvPr/>
-        </p:nvSpPr>
-        <p:spPr>
-          <a:xfrm>
-            <a:off x="566928" y="4526280"/>
-            <a:ext cx="146304" cy="146304"/>
-          </a:xfrm>
-          <a:prstGeom prst="rect">
-            <a:avLst/>
-          </a:prstGeom>
-          <a:solidFill>
-            <a:srgbClr val="E8763C"/>
-          </a:solidFill>
-          <a:ln/>
-        </p:spPr>
-      </p:sp>
-      <p:sp>
-        <p:nvSpPr>
-          <p:cNvPr id="16" name="Text 14"/>
-          <p:cNvSpPr/>
-          <p:nvPr/>
-        </p:nvSpPr>
-        <p:spPr>
-          <a:xfrm>
-            <a:off x="877824" y="4480560"/>
-            <a:ext cx="3657600" cy="685800"/>
-          </a:xfrm>
-          <a:prstGeom prst="rect">
-            <a:avLst/>
-          </a:prstGeom>
-          <a:noFill/>
-          <a:ln/>
-        </p:spPr>
-        <p:txBody>
-          <a:bodyPr wrap="square" lIns="0" tIns="0" rIns="0" bIns="0" rtlCol="0" anchor="t"/>
-          <a:lstStyle/>
-          <a:p>
-            <a:pPr indent="0" marL="0">
-              <a:buNone/>
-            </a:pPr>
-            <a:r>
-              <a:rPr lang="en-US" sz="1450" b="1" dirty="0">
-                <a:solidFill>
-                  <a:srgbClr val="1E2340"/>
-                </a:solidFill>
-                <a:latin typeface="Calibri" pitchFamily="34" charset="0"/>
-                <a:ea typeface="Calibri" pitchFamily="34" charset="-122"/>
-                <a:cs typeface="Calibri" pitchFamily="34" charset="-120"/>
-              </a:rPr>
-              <a:t>Single node, light theme only</a:t>
-            </a:r>
-            <a:endParaRPr lang="en-US" sz="1450" dirty="0"/>
-          </a:p>
-        </p:txBody>
-      </p:sp>
-      <p:sp>
-        <p:nvSpPr>
-          <p:cNvPr id="17" name="Text 15"/>
-          <p:cNvSpPr/>
-          <p:nvPr/>
-        </p:nvSpPr>
-        <p:spPr>
-          <a:xfrm>
-            <a:off x="4681728" y="4480560"/>
-            <a:ext cx="7223760" cy="685800"/>
-          </a:xfrm>
-          <a:prstGeom prst="rect">
-            <a:avLst/>
-          </a:prstGeom>
-          <a:noFill/>
-          <a:ln/>
-        </p:spPr>
-        <p:txBody>
-          <a:bodyPr wrap="square" lIns="0" tIns="0" rIns="0" bIns="0" rtlCol="0" anchor="t"/>
-          <a:lstStyle/>
-          <a:p>
-            <a:pPr indent="0" marL="0">
-              <a:buNone/>
-            </a:pPr>
-            <a:r>
-              <a:rPr lang="en-US" sz="1350" dirty="0">
-                <a:solidFill>
-                  <a:srgbClr val="6E7597"/>
-                </a:solidFill>
-                <a:latin typeface="Calibri" pitchFamily="34" charset="0"/>
-                <a:ea typeface="Calibri" pitchFamily="34" charset="-122"/>
-                <a:cs typeface="Calibri" pitchFamily="34" charset="-120"/>
-              </a:rPr>
-              <a:t>SQLite with a synchronous driver, and a design that commits to printed cream stock.</a:t>
-            </a:r>
-            <a:endParaRPr lang="en-US" sz="1350" dirty="0"/>
-          </a:p>
-        </p:txBody>
-      </p:sp>
-      <p:sp>
-        <p:nvSpPr>
-          <p:cNvPr id="18" name="Text 16"/>
-          <p:cNvSpPr/>
-          <p:nvPr/>
-        </p:nvSpPr>
-        <p:spPr>
-          <a:xfrm>
-            <a:off x="566928" y="5623560"/>
-            <a:ext cx="3657600" cy="320040"/>
-          </a:xfrm>
-          <a:prstGeom prst="rect">
-            <a:avLst/>
-          </a:prstGeom>
-          <a:noFill/>
-          <a:ln/>
-        </p:spPr>
-        <p:txBody>
-          <a:bodyPr wrap="square" lIns="0" tIns="0" rIns="0" bIns="0" rtlCol="0" anchor="ctr"/>
-          <a:lstStyle/>
-          <a:p>
-            <a:pPr indent="0" marL="0">
-              <a:buNone/>
-            </a:pPr>
-            <a:r>
-              <a:rPr lang="en-US" sz="1500" b="1" dirty="0">
-                <a:solidFill>
-                  <a:srgbClr val="2E5BD4"/>
-                </a:solidFill>
-                <a:latin typeface="Arial" pitchFamily="34" charset="0"/>
-                <a:ea typeface="Arial" pitchFamily="34" charset="-122"/>
-                <a:cs typeface="Arial" pitchFamily="34" charset="-120"/>
-              </a:rPr>
-              <a:t>Next, in order</a:t>
-            </a:r>
-            <a:endParaRPr lang="en-US" sz="1500" dirty="0"/>
-          </a:p>
-        </p:txBody>
-      </p:sp>
-      <p:sp>
-        <p:nvSpPr>
-          <p:cNvPr id="19" name="Text 17"/>
-          <p:cNvSpPr/>
-          <p:nvPr/>
-        </p:nvSpPr>
-        <p:spPr>
-          <a:xfrm>
-            <a:off x="566928" y="5943600"/>
-            <a:ext cx="11064240" cy="457200"/>
-          </a:xfrm>
-          <a:prstGeom prst="rect">
-            <a:avLst/>
-          </a:prstGeom>
-          <a:noFill/>
-          <a:ln/>
-        </p:spPr>
-        <p:txBody>
-          <a:bodyPr wrap="square" lIns="0" tIns="0" rIns="0" bIns="0" rtlCol="0" anchor="ctr"/>
-          <a:lstStyle/>
-          <a:p>
-            <a:pPr indent="0" marL="0">
-              <a:buNone/>
-            </a:pPr>
-            <a:r>
-              <a:rPr lang="en-US" sz="1300" dirty="0">
-                <a:solidFill>
-                  <a:srgbClr val="343B5C"/>
-                </a:solidFill>
-                <a:latin typeface="Calibri" pitchFamily="34" charset="0"/>
-                <a:ea typeface="Calibri" pitchFamily="34" charset="-122"/>
-                <a:cs typeface="Calibri" pitchFamily="34" charset="-120"/>
-              </a:rPr>
-              <a:t>Tests for the event writer and the export projection  ·  diagram labelling questions  ·  per-lesson drop-off  ·  a learner-facing view of their own data</a:t>
-            </a:r>
-            <a:endParaRPr lang="en-US" sz="1300" dirty="0"/>
-          </a:p>
-        </p:txBody>
-      </p:sp>
-    </p:spTree>
-  </p:cSld>
-  <p:clrMapOvr>
-    <a:masterClrMapping/>
-  </p:clrMapOvr>
-</p:sld>
-</file>
-
-<file path=ppt/slides/slide15.xml><?xml version="1.0" encoding="utf-8"?>
-<p:sld xmlns:a="http://schemas.openxmlformats.org/drawingml/2006/main" xmlns:r="http://schemas.openxmlformats.org/officeDocument/2006/relationships" xmlns:p="http://schemas.openxmlformats.org/presentationml/2006/main">
-  <p:cSld name="Slide 15">
     <p:bg>
       <p:bgPr>
         <a:solidFill>
@@ -5224,7 +4510,7 @@
                 <a:ea typeface="Arial" pitchFamily="34" charset="-122"/>
                 <a:cs typeface="Arial" pitchFamily="34" charset="-120"/>
               </a:rPr>
-              <a:t>1,610</a:t>
+              <a:t>2,206</a:t>
             </a:r>
             <a:endParaRPr lang="en-US" sz="3000" dirty="0"/>
           </a:p>
@@ -5458,7 +4744,7 @@
                 <a:ea typeface="Arial" pitchFamily="34" charset="-122"/>
                 <a:cs typeface="Arial" pitchFamily="34" charset="-120"/>
               </a:rPr>
-              <a:t>473</a:t>
+              <a:t>474</a:t>
             </a:r>
             <a:endParaRPr lang="en-US" sz="3000" dirty="0"/>
           </a:p>
@@ -6433,7 +5719,7 @@
                 <a:ea typeface="Arial" pitchFamily="34" charset="-122"/>
                 <a:cs typeface="Arial" pitchFamily="34" charset="-120"/>
               </a:rPr>
-              <a:t>1,610</a:t>
+              <a:t>2,206</a:t>
             </a:r>
             <a:endParaRPr lang="en-US" sz="3000" dirty="0"/>
           </a:p>
@@ -6556,7 +5842,7 @@
                 <a:ea typeface="Arial" pitchFamily="34" charset="-122"/>
                 <a:cs typeface="Arial" pitchFamily="34" charset="-120"/>
               </a:rPr>
-              <a:t>22</a:t>
+              <a:t>31</a:t>
             </a:r>
             <a:endParaRPr lang="en-US" sz="3000" dirty="0"/>
           </a:p>
@@ -6802,7 +6088,7 @@
                 <a:ea typeface="Arial" pitchFamily="34" charset="-122"/>
                 <a:cs typeface="Arial" pitchFamily="34" charset="-120"/>
               </a:rPr>
-              <a:t>473</a:t>
+              <a:t>474</a:t>
             </a:r>
             <a:endParaRPr lang="en-US" sz="3000" dirty="0"/>
           </a:p>
@@ -10812,7 +10098,7 @@
                 <a:ea typeface="Calibri" pitchFamily="34" charset="-122"/>
                 <a:cs typeface="Calibri" pitchFamily="34" charset="-120"/>
               </a:rPr>
-              <a:t>The drop-off chart is only possible because of the milestone events. 313 video events recorded so far.</a:t>
+              <a:t>The drop-off chart is only possible because of the milestone events. 360 video events recorded so far.</a:t>
             </a:r>
             <a:endParaRPr lang="en-US" sz="1500" dirty="0"/>
           </a:p>
@@ -12321,7 +11607,7 @@
                 <a:ea typeface="Calibri" pitchFamily="34" charset="-122"/>
                 <a:cs typeface="Calibri" pitchFamily="34" charset="-120"/>
               </a:rPr>
-              <a:t>1,610 rows stored so far, spanning eight days of seeded class activity. The export writes them in the reference order, with a byte order mark so Excel opens the UTF-8 correctly.</a:t>
+              <a:t>2,206 rows stored so far, spanning eight days of seeded class activity. The export writes them in the reference order, with a byte order mark so Excel opens the UTF-8 correctly.</a:t>
             </a:r>
             <a:endParaRPr lang="en-US" sz="1400" dirty="0"/>
           </a:p>

</xml_diff>